<commit_message>
Reporte 17 de marzo
</commit_message>
<xml_diff>
--- a/Reporte 130326.pptx
+++ b/Reporte 130326.pptx
@@ -29,17 +29,24 @@
   <p:notesSz cx="6858000" cy="9144000"/>
   <p:embeddedFontLst>
     <p:embeddedFont>
-      <p:font typeface="Montserrat" pitchFamily="2" charset="0"/>
+      <p:font typeface="Montserrat" panose="00000500000000000000" pitchFamily="2" charset="0"/>
       <p:regular r:id="rId19"/>
       <p:bold r:id="rId20"/>
       <p:italic r:id="rId21"/>
       <p:boldItalic r:id="rId22"/>
     </p:embeddedFont>
     <p:embeddedFont>
-      <p:font typeface="Montserrat Black" pitchFamily="2" charset="0"/>
+      <p:font typeface="Montserrat Black" panose="00000A00000000000000" pitchFamily="2" charset="0"/>
       <p:bold r:id="rId23"/>
       <p:italic r:id="rId24"/>
       <p:boldItalic r:id="rId25"/>
+    </p:embeddedFont>
+    <p:embeddedFont>
+      <p:font typeface="Segoe UI" panose="020B0502040204020203" pitchFamily="34" charset="0"/>
+      <p:regular r:id="rId26"/>
+      <p:bold r:id="rId27"/>
+      <p:italic r:id="rId28"/>
+      <p:boldItalic r:id="rId29"/>
     </p:embeddedFont>
   </p:embeddedFontLst>
   <p:defaultTextStyle>
@@ -6048,7 +6055,7 @@
                 <a:latin typeface="Montserrat Black"/>
                 <a:sym typeface="Arial"/>
               </a:rPr>
-              <a:t>Elaborado: 12</a:t>
+              <a:t>Elaborado: 13</a:t>
             </a:r>
             <a:r>
               <a:rPr lang="es-MX" sz="1600" dirty="0">
@@ -6174,10 +6181,10 @@
       </p:sp>
       <p:pic>
         <p:nvPicPr>
-          <p:cNvPr id="4" name="Imagen 3">
+          <p:cNvPr id="7" name="Imagen 6">
             <a:extLst>
               <a:ext uri="{FF2B5EF4-FFF2-40B4-BE49-F238E27FC236}">
-                <a16:creationId xmlns:a16="http://schemas.microsoft.com/office/drawing/2014/main" id="{E0BF1F0F-70BE-EA11-36CA-0BCD9911D900}"/>
+                <a16:creationId xmlns:a16="http://schemas.microsoft.com/office/drawing/2014/main" id="{2FCDB21B-6230-ACE6-BE7D-2AFCB9C576B3}"/>
               </a:ext>
             </a:extLst>
           </p:cNvPr>
@@ -6194,8 +6201,8 @@
         </p:blipFill>
         <p:spPr>
           <a:xfrm>
-            <a:off x="0" y="733206"/>
-            <a:ext cx="9144000" cy="3677088"/>
+            <a:off x="0" y="343275"/>
+            <a:ext cx="9144000" cy="4456950"/>
           </a:xfrm>
           <a:prstGeom prst="rect">
             <a:avLst/>
@@ -6272,10 +6279,10 @@
       </p:sp>
       <p:pic>
         <p:nvPicPr>
-          <p:cNvPr id="5" name="Imagen 4">
+          <p:cNvPr id="7" name="Imagen 6">
             <a:extLst>
               <a:ext uri="{FF2B5EF4-FFF2-40B4-BE49-F238E27FC236}">
-                <a16:creationId xmlns:a16="http://schemas.microsoft.com/office/drawing/2014/main" id="{E2BE9A5D-E0E5-90ED-CB9D-2028548C0CE6}"/>
+                <a16:creationId xmlns:a16="http://schemas.microsoft.com/office/drawing/2014/main" id="{66C771C4-7F09-420B-9DD1-96E82C3B3EB7}"/>
               </a:ext>
             </a:extLst>
           </p:cNvPr>
@@ -6292,8 +6299,8 @@
         </p:blipFill>
         <p:spPr>
           <a:xfrm>
-            <a:off x="0" y="861710"/>
-            <a:ext cx="9144000" cy="3420080"/>
+            <a:off x="0" y="876826"/>
+            <a:ext cx="9144000" cy="3389848"/>
           </a:xfrm>
           <a:prstGeom prst="rect">
             <a:avLst/>
@@ -6370,10 +6377,10 @@
       </p:sp>
       <p:pic>
         <p:nvPicPr>
-          <p:cNvPr id="4" name="Imagen 3">
+          <p:cNvPr id="3" name="Imagen 2">
             <a:extLst>
               <a:ext uri="{FF2B5EF4-FFF2-40B4-BE49-F238E27FC236}">
-                <a16:creationId xmlns:a16="http://schemas.microsoft.com/office/drawing/2014/main" id="{FD98A8CB-CFAE-9695-3A65-FFCD89C99590}"/>
+                <a16:creationId xmlns:a16="http://schemas.microsoft.com/office/drawing/2014/main" id="{3E39F1B1-78FE-E6FC-E82A-1805BC491DC8}"/>
               </a:ext>
             </a:extLst>
           </p:cNvPr>
@@ -6390,8 +6397,8 @@
         </p:blipFill>
         <p:spPr>
           <a:xfrm>
-            <a:off x="0" y="1354429"/>
-            <a:ext cx="9144000" cy="2434641"/>
+            <a:off x="0" y="1224822"/>
+            <a:ext cx="9144000" cy="2693855"/>
           </a:xfrm>
           <a:prstGeom prst="rect">
             <a:avLst/>
@@ -6468,10 +6475,10 @@
       </p:sp>
       <p:pic>
         <p:nvPicPr>
-          <p:cNvPr id="4" name="Imagen 3">
+          <p:cNvPr id="3" name="Imagen 2">
             <a:extLst>
               <a:ext uri="{FF2B5EF4-FFF2-40B4-BE49-F238E27FC236}">
-                <a16:creationId xmlns:a16="http://schemas.microsoft.com/office/drawing/2014/main" id="{F02FF624-91D7-7E42-2C7A-B22D061D6CB7}"/>
+                <a16:creationId xmlns:a16="http://schemas.microsoft.com/office/drawing/2014/main" id="{9C0EB269-54C8-5EC2-19BF-1F5E7A630C24}"/>
               </a:ext>
             </a:extLst>
           </p:cNvPr>
@@ -6488,8 +6495,8 @@
         </p:blipFill>
         <p:spPr>
           <a:xfrm>
-            <a:off x="0" y="1345681"/>
-            <a:ext cx="9144000" cy="2452138"/>
+            <a:off x="0" y="1320042"/>
+            <a:ext cx="9144000" cy="2503415"/>
           </a:xfrm>
           <a:prstGeom prst="rect">
             <a:avLst/>
@@ -6572,49 +6579,32 @@
       </p:sp>
       <p:pic>
         <p:nvPicPr>
-          <p:cNvPr id="1026" name="Picture 2">
+          <p:cNvPr id="3" name="Imagen 2">
             <a:extLst>
               <a:ext uri="{FF2B5EF4-FFF2-40B4-BE49-F238E27FC236}">
-                <a16:creationId xmlns:a16="http://schemas.microsoft.com/office/drawing/2014/main" id="{ADF69307-6B94-33B8-D22C-00D4513CC3C0}"/>
+                <a16:creationId xmlns:a16="http://schemas.microsoft.com/office/drawing/2014/main" id="{7A0CB5EC-60D9-1209-C774-48F8FA7C5C97}"/>
               </a:ext>
             </a:extLst>
           </p:cNvPr>
           <p:cNvPicPr>
-            <a:picLocks noChangeAspect="1" noChangeArrowheads="1"/>
+            <a:picLocks noChangeAspect="1"/>
           </p:cNvPicPr>
           <p:nvPr/>
         </p:nvPicPr>
         <p:blipFill>
-          <a:blip r:embed="rId2">
-            <a:extLst>
-              <a:ext uri="{28A0092B-C50C-407E-A947-70E740481C1C}">
-                <a14:useLocalDpi xmlns:a14="http://schemas.microsoft.com/office/drawing/2010/main" val="0"/>
-              </a:ext>
-            </a:extLst>
-          </a:blip>
-          <a:srcRect/>
+          <a:blip r:embed="rId2"/>
           <a:stretch>
             <a:fillRect/>
           </a:stretch>
         </p:blipFill>
-        <p:spPr bwMode="auto">
+        <p:spPr>
           <a:xfrm>
-            <a:off x="2090738" y="666750"/>
-            <a:ext cx="4962525" cy="3810000"/>
+            <a:off x="0" y="762310"/>
+            <a:ext cx="9144000" cy="3618879"/>
           </a:xfrm>
           <a:prstGeom prst="rect">
             <a:avLst/>
           </a:prstGeom>
-          <a:noFill/>
-          <a:extLst>
-            <a:ext uri="{909E8E84-426E-40DD-AFC4-6F175D3DCCD1}">
-              <a14:hiddenFill xmlns:a14="http://schemas.microsoft.com/office/drawing/2010/main">
-                <a:solidFill>
-                  <a:srgbClr val="FFFFFF"/>
-                </a:solidFill>
-              </a14:hiddenFill>
-            </a:ext>
-          </a:extLst>
         </p:spPr>
       </p:pic>
     </p:spTree>
@@ -6647,12 +6637,55 @@
           <a:chExt cx="0" cy="0"/>
         </a:xfrm>
       </p:grpSpPr>
+      <p:sp>
+        <p:nvSpPr>
+          <p:cNvPr id="5" name="CuadroTexto 4">
+            <a:extLst>
+              <a:ext uri="{FF2B5EF4-FFF2-40B4-BE49-F238E27FC236}">
+                <a16:creationId xmlns:a16="http://schemas.microsoft.com/office/drawing/2014/main" id="{23CD2619-00B8-8B02-6415-81CE05D5337A}"/>
+              </a:ext>
+            </a:extLst>
+          </p:cNvPr>
+          <p:cNvSpPr txBox="1"/>
+          <p:nvPr/>
+        </p:nvSpPr>
+        <p:spPr>
+          <a:xfrm>
+            <a:off x="2249488" y="0"/>
+            <a:ext cx="4572000" cy="338554"/>
+          </a:xfrm>
+          <a:prstGeom prst="rect">
+            <a:avLst/>
+          </a:prstGeom>
+          <a:noFill/>
+        </p:spPr>
+        <p:txBody>
+          <a:bodyPr wrap="square">
+            <a:spAutoFit/>
+          </a:bodyPr>
+          <a:lstStyle/>
+          <a:p>
+            <a:pPr algn="ctr"/>
+            <a:r>
+              <a:rPr lang="es-MX" sz="1600" b="1" i="0" dirty="0">
+                <a:solidFill>
+                  <a:srgbClr val="611232"/>
+                </a:solidFill>
+                <a:effectLst/>
+                <a:latin typeface="Segoe UI" panose="020B0502040204020203" pitchFamily="34" charset="0"/>
+              </a:rPr>
+              <a:t>Información Emitida por Radioescucha</a:t>
+            </a:r>
+            <a:endParaRPr lang="es-MX" sz="1600" dirty="0"/>
+          </a:p>
+        </p:txBody>
+      </p:sp>
       <p:pic>
         <p:nvPicPr>
-          <p:cNvPr id="7" name="Imagen 6">
+          <p:cNvPr id="8" name="Imagen 7">
             <a:extLst>
               <a:ext uri="{FF2B5EF4-FFF2-40B4-BE49-F238E27FC236}">
-                <a16:creationId xmlns:a16="http://schemas.microsoft.com/office/drawing/2014/main" id="{B8AA6159-06D0-1EE1-8265-4557BB321BF0}"/>
+                <a16:creationId xmlns:a16="http://schemas.microsoft.com/office/drawing/2014/main" id="{251A0EDC-7AE9-CA3E-AE4E-E533A9BEC3B8}"/>
               </a:ext>
             </a:extLst>
           </p:cNvPr>
@@ -6669,8 +6702,8 @@
         </p:blipFill>
         <p:spPr>
           <a:xfrm>
-            <a:off x="0" y="756243"/>
-            <a:ext cx="9144000" cy="3631014"/>
+            <a:off x="0" y="779203"/>
+            <a:ext cx="9144000" cy="3585093"/>
           </a:xfrm>
           <a:prstGeom prst="rect">
             <a:avLst/>
@@ -7807,10 +7840,10 @@
       </p:sp>
       <p:pic>
         <p:nvPicPr>
-          <p:cNvPr id="5" name="Imagen 4">
+          <p:cNvPr id="7" name="Imagen 6">
             <a:extLst>
               <a:ext uri="{FF2B5EF4-FFF2-40B4-BE49-F238E27FC236}">
-                <a16:creationId xmlns:a16="http://schemas.microsoft.com/office/drawing/2014/main" id="{B6EB1AF5-A795-1D83-4D83-D3E4D2B7B015}"/>
+                <a16:creationId xmlns:a16="http://schemas.microsoft.com/office/drawing/2014/main" id="{96A372B4-63F3-FAF1-8E59-FBD58568581F}"/>
               </a:ext>
             </a:extLst>
           </p:cNvPr>
@@ -7827,8 +7860,8 @@
         </p:blipFill>
         <p:spPr>
           <a:xfrm>
-            <a:off x="0" y="525162"/>
-            <a:ext cx="9144000" cy="4093176"/>
+            <a:off x="0" y="415478"/>
+            <a:ext cx="9144000" cy="4455419"/>
           </a:xfrm>
           <a:prstGeom prst="rect">
             <a:avLst/>
@@ -7905,10 +7938,10 @@
       </p:sp>
       <p:pic>
         <p:nvPicPr>
-          <p:cNvPr id="4" name="Imagen 3">
+          <p:cNvPr id="9" name="Imagen 8">
             <a:extLst>
               <a:ext uri="{FF2B5EF4-FFF2-40B4-BE49-F238E27FC236}">
-                <a16:creationId xmlns:a16="http://schemas.microsoft.com/office/drawing/2014/main" id="{BCEC340A-5074-17C7-E9DE-9812AF6884FA}"/>
+                <a16:creationId xmlns:a16="http://schemas.microsoft.com/office/drawing/2014/main" id="{8240F420-9EB0-E344-6232-BE9487166FA0}"/>
               </a:ext>
             </a:extLst>
           </p:cNvPr>
@@ -7925,8 +7958,8 @@
         </p:blipFill>
         <p:spPr>
           <a:xfrm>
-            <a:off x="0" y="959438"/>
-            <a:ext cx="9144000" cy="3224623"/>
+            <a:off x="0" y="1005867"/>
+            <a:ext cx="9144000" cy="3274642"/>
           </a:xfrm>
           <a:prstGeom prst="rect">
             <a:avLst/>

</xml_diff>